<commit_message>
Fix domestic fatal news and simplify safety portal entry points
</commit_message>
<xml_diff>
--- a/web/public/training/safety-seminars/safety-management-basics-osh-law/downloads/safety-management-basics-osh-law-training.pptx
+++ b/web/public/training/safety-seminars/safety-management-basics-osh-law/downloads/safety-management-basics-osh-law-training.pptx
@@ -521,7 +521,7 @@
 主張ID
 C-REF-CYCLE
 [Sources]
-- S1 REF-SAFETY-PDF-CH01: https://drive.google.com/drive/folders/1ueL4tATdCiIuiUKCluDlov1CLCo56FGn?usp=drive_link</a:t>
+- S3 GUIDE-MHLW-OSHMS: https://www.mhlw.go.jp/content/11200000/000591670.pdf</a:t>
             </a:r>
             <a:endParaRPr lang="en-US" dirty="0"/>
           </a:p>
@@ -617,8 +617,8 @@
 主張ID
 C-GUIDE-RA, C-GUIDE-CONTROLS, C-LAW-TRAINING
 [Sources]
-- S5 GUIDE-MHLW-RA: https://www.mhlw.go.jp/web/t_doc?dataId=00tb3050&amp;dataType=1&amp;pageNo=1
-- S2 LAW-MHLW-OSH: https://www.mhlw.go.jp/web/t_doc?dataId=74001000</a:t>
+- S4 GUIDE-MHLW-RA: https://www.mhlw.go.jp/web/t_doc?dataId=00tb3050&amp;dataType=1&amp;pageNo=1
+- S1 LAW-MHLW-OSH: https://laws.e-gov.go.jp/law/347AC0000000057</a:t>
             </a:r>
             <a:endParaRPr lang="en-US" dirty="0"/>
           </a:p>
@@ -714,8 +714,9 @@
 主張ID
 C-GUIDE-RA, C-REF-CYCLE, C-REF-ROLE
 [Sources]
-- S5 GUIDE-MHLW-RA: https://www.mhlw.go.jp/web/t_doc?dataId=00tb3050&amp;dataType=1&amp;pageNo=1
-- S1 REF-SAFETY-PDF-CH01: https://drive.google.com/drive/folders/1ueL4tATdCiIuiUKCluDlov1CLCo56FGn?usp=drive_link</a:t>
+- S4 GUIDE-MHLW-RA: https://www.mhlw.go.jp/web/t_doc?dataId=00tb3050&amp;dataType=1&amp;pageNo=1
+- S3 GUIDE-MHLW-OSHMS: https://www.mhlw.go.jp/content/11200000/000591670.pdf
+- S1 LAW-MHLW-OSH: https://laws.e-gov.go.jp/law/347AC0000000057</a:t>
             </a:r>
             <a:endParaRPr lang="en-US" dirty="0"/>
           </a:p>
@@ -811,8 +812,8 @@
 主張ID
 C-REF-MULTI, C-GUIDE-RA, C-GUIDE-CONTROLS, C-REF-ROLE
 [Sources]
-- S1 REF-SAFETY-PDF-CH01: https://drive.google.com/drive/folders/1ueL4tATdCiIuiUKCluDlov1CLCo56FGn?usp=drive_link
-- S5 GUIDE-MHLW-RA: https://www.mhlw.go.jp/web/t_doc?dataId=00tb3050&amp;dataType=1&amp;pageNo=1</a:t>
+- S1 LAW-MHLW-OSH: https://laws.e-gov.go.jp/law/347AC0000000057
+- S4 GUIDE-MHLW-RA: https://www.mhlw.go.jp/web/t_doc?dataId=00tb3050&amp;dataType=1&amp;pageNo=1</a:t>
             </a:r>
             <a:endParaRPr lang="en-US" dirty="0"/>
           </a:p>
@@ -908,7 +909,8 @@
 主張ID
 C-REF-MULTI
 [Sources]
-- S1 REF-SAFETY-PDF-CH01: https://drive.google.com/drive/folders/1ueL4tATdCiIuiUKCluDlov1CLCo56FGn?usp=drive_link</a:t>
+- S1 LAW-MHLW-OSH: https://laws.e-gov.go.jp/law/347AC0000000057
+- S4 GUIDE-MHLW-RA: https://www.mhlw.go.jp/web/t_doc?dataId=00tb3050&amp;dataType=1&amp;pageNo=1</a:t>
             </a:r>
             <a:endParaRPr lang="en-US" dirty="0"/>
           </a:p>
@@ -1004,7 +1006,7 @@
 主張ID
 C-LAW-PURPOSE, C-LAW-EMPLOYER
 [Sources]
-- S2 LAW-MHLW-OSH: https://www.mhlw.go.jp/web/t_doc?dataId=74001000</a:t>
+- S1 LAW-MHLW-OSH: https://laws.e-gov.go.jp/law/347AC0000000057</a:t>
             </a:r>
             <a:endParaRPr lang="en-US" dirty="0"/>
           </a:p>
@@ -1100,8 +1102,8 @@
 主張ID
 C-LAW-PURPOSE, C-LAW-FUTURE
 [Sources]
-- S2 LAW-MHLW-OSH: https://www.mhlw.go.jp/web/t_doc?dataId=74001000
-- S3 LAW-R7-33-AMENDMENT: https://www.mhlw.go.jp/content/11300000/001497670.pdf</a:t>
+- S1 LAW-MHLW-OSH: https://laws.e-gov.go.jp/law/347AC0000000057
+- S2 LAW-R7-33-AMENDMENT: https://www.mhlw.go.jp/content/11300000/001497670.pdf</a:t>
             </a:r>
             <a:endParaRPr lang="en-US" dirty="0"/>
           </a:p>
@@ -1197,9 +1199,8 @@
 主張ID
 C-REF-ROLE, C-LAW-COORDINATION, C-LAW-WORKER
 [Sources]
-- S1 REF-SAFETY-PDF-CH01: https://drive.google.com/drive/folders/1ueL4tATdCiIuiUKCluDlov1CLCo56FGn?usp=drive_link
-- S2 LAW-MHLW-OSH: https://www.mhlw.go.jp/web/t_doc?dataId=74001000
-- S3 LAW-R7-33-AMENDMENT: https://www.mhlw.go.jp/content/11300000/001497670.pdf</a:t>
+- S1 LAW-MHLW-OSH: https://laws.e-gov.go.jp/law/347AC0000000057
+- S2 LAW-R7-33-AMENDMENT: https://www.mhlw.go.jp/content/11300000/001497670.pdf</a:t>
             </a:r>
             <a:endParaRPr lang="en-US" dirty="0"/>
           </a:p>
@@ -1295,7 +1296,7 @@
 主張ID
 C-GUIDE-OSHMS
 [Sources]
-- S4 GUIDE-MHLW-OSHMS: https://www.mhlw.go.jp/content/11200000/000591670.pdf</a:t>
+- S3 GUIDE-MHLW-OSHMS: https://www.mhlw.go.jp/content/11200000/000591670.pdf</a:t>
             </a:r>
             <a:endParaRPr lang="en-US" dirty="0"/>
           </a:p>
@@ -1391,7 +1392,7 @@
 主張ID
 C-GUIDE-RA
 [Sources]
-- S5 GUIDE-MHLW-RA: https://www.mhlw.go.jp/web/t_doc?dataId=00tb3050&amp;dataType=1&amp;pageNo=1</a:t>
+- S4 GUIDE-MHLW-RA: https://www.mhlw.go.jp/web/t_doc?dataId=00tb3050&amp;dataType=1&amp;pageNo=1</a:t>
             </a:r>
             <a:endParaRPr lang="en-US" dirty="0"/>
           </a:p>
@@ -1487,7 +1488,7 @@
 主張ID
 C-GUIDE-RA
 [Sources]
-- S5 GUIDE-MHLW-RA: https://www.mhlw.go.jp/web/t_doc?dataId=00tb3050&amp;dataType=1&amp;pageNo=1</a:t>
+- S4 GUIDE-MHLW-RA: https://www.mhlw.go.jp/web/t_doc?dataId=00tb3050&amp;dataType=1&amp;pageNo=1</a:t>
             </a:r>
             <a:endParaRPr lang="en-US" dirty="0"/>
           </a:p>
@@ -1583,7 +1584,7 @@
 主張ID
 C-GUIDE-CONTROLS
 [Sources]
-- S5 GUIDE-MHLW-RA: https://www.mhlw.go.jp/web/t_doc?dataId=00tb3050&amp;dataType=1&amp;pageNo=1</a:t>
+- S4 GUIDE-MHLW-RA: https://www.mhlw.go.jp/web/t_doc?dataId=00tb3050&amp;dataType=1&amp;pageNo=1</a:t>
             </a:r>
             <a:endParaRPr lang="en-US" dirty="0"/>
           </a:p>
@@ -3382,7 +3383,7 @@
                 <a:ea typeface="Yu Gothic" pitchFamily="34" charset="-122"/>
                 <a:cs typeface="Yu Gothic" pitchFamily="34" charset="-120"/>
               </a:rPr>
-              <a:t>出典 S5・S2（詳細はノート）</a:t>
+              <a:t>根拠 安衛法 第59条・第61条（詳細はノート）</a:t>
             </a:r>
             <a:endParaRPr lang="en-US" sz="980" dirty="0"/>
           </a:p>
@@ -4382,7 +4383,7 @@
                 <a:ea typeface="Yu Gothic" pitchFamily="34" charset="-122"/>
                 <a:cs typeface="Yu Gothic" pitchFamily="34" charset="-120"/>
               </a:rPr>
-              <a:t>出典 S5・S1（詳細はノート）</a:t>
+              <a:t>根拠 安衛法 第29条・第30条（詳細はノート）</a:t>
             </a:r>
             <a:endParaRPr lang="en-US" sz="980" dirty="0"/>
           </a:p>
@@ -5564,7 +5565,7 @@
                 <a:ea typeface="Yu Gothic" pitchFamily="34" charset="-122"/>
                 <a:cs typeface="Yu Gothic" pitchFamily="34" charset="-120"/>
               </a:rPr>
-              <a:t>出典 S1（詳細はノート）</a:t>
+              <a:t>根拠 安衛法 第28条の2（詳細はノート）</a:t>
             </a:r>
             <a:endParaRPr lang="en-US" sz="980" dirty="0"/>
           </a:p>
@@ -6414,7 +6415,7 @@
                 <a:ea typeface="Yu Gothic" pitchFamily="34" charset="-122"/>
                 <a:cs typeface="Yu Gothic" pitchFamily="34" charset="-120"/>
               </a:rPr>
-              <a:t>出典 S2（詳細はノート）</a:t>
+              <a:t>根拠 安衛法 第1条・第3条（詳細はノート）</a:t>
             </a:r>
             <a:endParaRPr lang="en-US" sz="980" dirty="0"/>
           </a:p>
@@ -7414,7 +7415,7 @@
                 <a:ea typeface="Yu Gothic" pitchFamily="34" charset="-122"/>
                 <a:cs typeface="Yu Gothic" pitchFamily="34" charset="-120"/>
               </a:rPr>
-              <a:t>出典 S2・S3（詳細はノート）</a:t>
+              <a:t>根拠 安衛法 第1条（詳細はノート）</a:t>
             </a:r>
             <a:endParaRPr lang="en-US" sz="980" dirty="0"/>
           </a:p>
@@ -8264,7 +8265,7 @@
                 <a:ea typeface="Yu Gothic" pitchFamily="34" charset="-122"/>
                 <a:cs typeface="Yu Gothic" pitchFamily="34" charset="-120"/>
               </a:rPr>
-              <a:t>出典 S1・S2・S3（詳細はノート）</a:t>
+              <a:t>根拠 安衛法 第29条・第30条（詳細はノート）</a:t>
             </a:r>
             <a:endParaRPr lang="en-US" sz="980" dirty="0"/>
           </a:p>
@@ -9264,7 +9265,7 @@
                 <a:ea typeface="Yu Gothic" pitchFamily="34" charset="-122"/>
                 <a:cs typeface="Yu Gothic" pitchFamily="34" charset="-120"/>
               </a:rPr>
-              <a:t>出典 S4（詳細はノート）</a:t>
+              <a:t>出典 S3（詳細はノート）</a:t>
             </a:r>
             <a:endParaRPr lang="en-US" sz="980" dirty="0"/>
           </a:p>
@@ -10264,7 +10265,7 @@
                 <a:ea typeface="Yu Gothic" pitchFamily="34" charset="-122"/>
                 <a:cs typeface="Yu Gothic" pitchFamily="34" charset="-120"/>
               </a:rPr>
-              <a:t>出典 S5（詳細はノート）</a:t>
+              <a:t>出典 S4（詳細はノート）</a:t>
             </a:r>
             <a:endParaRPr lang="en-US" sz="980" dirty="0"/>
           </a:p>
@@ -11156,7 +11157,7 @@
                 <a:ea typeface="Yu Gothic" pitchFamily="34" charset="-122"/>
                 <a:cs typeface="Yu Gothic" pitchFamily="34" charset="-120"/>
               </a:rPr>
-              <a:t>出典 S5（詳細はノート）</a:t>
+              <a:t>出典 S4（詳細はノート）</a:t>
             </a:r>
             <a:endParaRPr lang="en-US" sz="980" dirty="0"/>
           </a:p>
@@ -12156,7 +12157,7 @@
                 <a:ea typeface="Yu Gothic" pitchFamily="34" charset="-122"/>
                 <a:cs typeface="Yu Gothic" pitchFamily="34" charset="-120"/>
               </a:rPr>
-              <a:t>出典 S5（詳細はノート）</a:t>
+              <a:t>出典 S4（詳細はノート）</a:t>
             </a:r>
             <a:endParaRPr lang="en-US" sz="980" dirty="0"/>
           </a:p>

</xml_diff>